<commit_message>
style: slide 1 — team names on right side, DORA line removed, Jatin Madaan corrected
</commit_message>
<xml_diff>
--- a/RegSentinel_5Slides.pptx
+++ b/RegSentinel_5Slides.pptx
@@ -1499,7 +1499,7 @@
                 <a:ea typeface="Arial" pitchFamily="34" charset="-122"/>
                 <a:cs typeface="Arial" pitchFamily="34" charset="-120"/>
               </a:rPr>
-              <a:t>AI-Powered EU Compliance Workstation</a:t>
+              <a:t>AI-Powered EU Compliance Workstation  ·  by ByteBrigade</a:t>
             </a:r>
             <a:endParaRPr lang="en-US" sz="2000" dirty="0"/>
           </a:p>
@@ -1507,30 +1507,30 @@
       </p:sp>
       <p:sp>
         <p:nvSpPr>
-          <p:cNvPr id="11" name="Text 9"/>
-          <p:cNvSpPr/>
-          <p:nvPr/>
-        </p:nvSpPr>
-        <p:spPr>
-          <a:xfrm>
-            <a:off x="457200" y="2578608"/>
-            <a:ext cx="7772400" cy="347472"/>
-          </a:xfrm>
-          <a:prstGeom prst="rect">
-            <a:avLst/>
-          </a:prstGeom>
-          <a:noFill/>
-          <a:ln/>
-        </p:spPr>
-        <p:txBody>
-          <a:bodyPr wrap="square" rtlCol="0" anchor="ctr"/>
-          <a:lstStyle/>
-          <a:p>
-            <a:pPr indent="0" marL="0">
-              <a:buNone/>
-            </a:pPr>
-            <a:r>
-              <a:rPr lang="en-US" sz="1400" b="1" dirty="0">
+          <p:cNvPr id="12" name="Text 10"/>
+          <p:cNvSpPr/>
+          <p:nvPr/>
+        </p:nvSpPr>
+        <p:spPr>
+          <a:xfrm>
+            <a:off x="7955279" y="3520440"/>
+            <a:ext cx="4023360" cy="2834640"/>
+          </a:xfrm>
+          <a:prstGeom prst="rect">
+            <a:avLst/>
+          </a:prstGeom>
+          <a:noFill/>
+          <a:ln/>
+        </p:spPr>
+        <p:txBody>
+          <a:bodyPr wrap="square" lIns="91440" tIns="45720" rIns="91440" bIns="45720" rtlCol="0" anchor="t"/>
+          <a:lstStyle/>
+          <a:p>
+            <a:pPr marL="0" indent="0">
+              <a:buNone/>
+            </a:pPr>
+            <a:r>
+              <a:rPr lang="en-US" sz="1600" b="1" dirty="0">
                 <a:solidFill>
                   <a:srgbClr val="1E2A78"/>
                 </a:solidFill>
@@ -1538,51 +1538,122 @@
                 <a:ea typeface="Arial" pitchFamily="34" charset="-122"/>
                 <a:cs typeface="Arial" pitchFamily="34" charset="-120"/>
               </a:rPr>
-              <a:t>DORA  ·  EU AI Act  ·  Dual-Framework Intelligence</a:t>
-            </a:r>
-            <a:endParaRPr lang="en-US" sz="1400" dirty="0"/>
-          </a:p>
-        </p:txBody>
-      </p:sp>
-      <p:sp>
-        <p:nvSpPr>
-          <p:cNvPr id="12" name="Text 10"/>
-          <p:cNvSpPr/>
-          <p:nvPr/>
-        </p:nvSpPr>
-        <p:spPr>
-          <a:xfrm>
-            <a:off x="457200" y="3090672"/>
-            <a:ext cx="7315200" cy="914400"/>
-          </a:xfrm>
-          <a:prstGeom prst="rect">
-            <a:avLst/>
-          </a:prstGeom>
-          <a:noFill/>
-          <a:ln/>
-        </p:spPr>
-        <p:txBody>
-          <a:bodyPr wrap="square" rtlCol="0" anchor="ctr"/>
-          <a:lstStyle/>
-          <a:p>
-            <a:pPr indent="0" marL="0">
-              <a:lnSpc>
-                <a:spcPct val="150000"/>
-              </a:lnSpc>
-              <a:buNone/>
-            </a:pPr>
-            <a:r>
-              <a:rPr lang="en-US" sz="1200" dirty="0">
-                <a:solidFill>
-                  <a:srgbClr val="4A6080"/>
-                </a:solidFill>
-                <a:latin typeface="Arial" pitchFamily="34" charset="0"/>
-                <a:ea typeface="Arial" pitchFamily="34" charset="-122"/>
-                <a:cs typeface="Arial" pitchFamily="34" charset="-120"/>
-              </a:rPr>
-              <a:t>An agentic compliance workstation that takes any DB Application ID and delivers live application details, WALTZ data flows, ServiceNow incidents, and an AI-powered regulatory analysis against DORA and the EU AI Act — simultaneously.</a:t>
-            </a:r>
-            <a:endParaRPr lang="en-US" sz="1200" dirty="0"/>
+              <a:t>Team ByteBrigade</a:t>
+            </a:r>
+          </a:p>
+          <a:p>
+            <a:pPr marL="0" indent="0">
+              <a:spcBef>
+                <a:spcPts val="120"/>
+              </a:spcBef>
+              <a:buNone/>
+            </a:pPr>
+            <a:r>
+              <a:rPr lang="en-US" sz="1400" dirty="0">
+                <a:solidFill>
+                  <a:srgbClr val="16184E"/>
+                </a:solidFill>
+                <a:latin typeface="Arial" pitchFamily="34" charset="0"/>
+                <a:ea typeface="Arial" pitchFamily="34" charset="-122"/>
+                <a:cs typeface="Arial" pitchFamily="34" charset="-120"/>
+              </a:rPr>
+              <a:t>Amit Yadav</a:t>
+            </a:r>
+          </a:p>
+          <a:p>
+            <a:pPr marL="0" indent="0">
+              <a:spcBef>
+                <a:spcPts val="120"/>
+              </a:spcBef>
+              <a:buNone/>
+            </a:pPr>
+            <a:r>
+              <a:rPr lang="en-US" sz="1400" dirty="0">
+                <a:solidFill>
+                  <a:srgbClr val="16184E"/>
+                </a:solidFill>
+                <a:latin typeface="Arial" pitchFamily="34" charset="0"/>
+                <a:ea typeface="Arial" pitchFamily="34" charset="-122"/>
+                <a:cs typeface="Arial" pitchFamily="34" charset="-120"/>
+              </a:rPr>
+              <a:t>Jatin Madaan</a:t>
+            </a:r>
+          </a:p>
+          <a:p>
+            <a:pPr marL="0" indent="0">
+              <a:spcBef>
+                <a:spcPts val="120"/>
+              </a:spcBef>
+              <a:buNone/>
+            </a:pPr>
+            <a:r>
+              <a:rPr lang="en-US" sz="1400" dirty="0">
+                <a:solidFill>
+                  <a:srgbClr val="16184E"/>
+                </a:solidFill>
+                <a:latin typeface="Arial" pitchFamily="34" charset="0"/>
+                <a:ea typeface="Arial" pitchFamily="34" charset="-122"/>
+                <a:cs typeface="Arial" pitchFamily="34" charset="-120"/>
+              </a:rPr>
+              <a:t>Nikhil Parchure</a:t>
+            </a:r>
+          </a:p>
+          <a:p>
+            <a:pPr marL="0" indent="0">
+              <a:spcBef>
+                <a:spcPts val="120"/>
+              </a:spcBef>
+              <a:buNone/>
+            </a:pPr>
+            <a:r>
+              <a:rPr lang="en-US" sz="1400" dirty="0">
+                <a:solidFill>
+                  <a:srgbClr val="16184E"/>
+                </a:solidFill>
+                <a:latin typeface="Arial" pitchFamily="34" charset="0"/>
+                <a:ea typeface="Arial" pitchFamily="34" charset="-122"/>
+                <a:cs typeface="Arial" pitchFamily="34" charset="-120"/>
+              </a:rPr>
+              <a:t>Ripu Lal</a:t>
+            </a:r>
+          </a:p>
+          <a:p>
+            <a:pPr marL="0" indent="0">
+              <a:spcBef>
+                <a:spcPts val="120"/>
+              </a:spcBef>
+              <a:buNone/>
+            </a:pPr>
+            <a:r>
+              <a:rPr lang="en-US" sz="1400" dirty="0">
+                <a:solidFill>
+                  <a:srgbClr val="16184E"/>
+                </a:solidFill>
+                <a:latin typeface="Arial" pitchFamily="34" charset="0"/>
+                <a:ea typeface="Arial" pitchFamily="34" charset="-122"/>
+                <a:cs typeface="Arial" pitchFamily="34" charset="-120"/>
+              </a:rPr>
+              <a:t>Saurabh Jain</a:t>
+            </a:r>
+          </a:p>
+          <a:p>
+            <a:pPr marL="0" indent="0">
+              <a:spcBef>
+                <a:spcPts val="120"/>
+              </a:spcBef>
+              <a:buNone/>
+            </a:pPr>
+            <a:r>
+              <a:rPr lang="en-US" sz="1400" dirty="0">
+                <a:solidFill>
+                  <a:srgbClr val="16184E"/>
+                </a:solidFill>
+                <a:latin typeface="Arial" pitchFamily="34" charset="0"/>
+                <a:ea typeface="Arial" pitchFamily="34" charset="-122"/>
+                <a:cs typeface="Arial" pitchFamily="34" charset="-120"/>
+              </a:rPr>
+              <a:t>Tushar Bholane</a:t>
+            </a:r>
           </a:p>
         </p:txBody>
       </p:sp>
@@ -4399,7 +4470,7 @@
                 <a:ea typeface="Arial" pitchFamily="34" charset="-122"/>
                 <a:cs typeface="Arial" pitchFamily="34" charset="-120"/>
               </a:rPr>
-              <a:t>Five Steps — Try it now: https://reg-sentinel-bumble-b-685865318522.europe-west1.run.app</a:t>
+              <a:t>Five Steps from App ID to Regulatory Action</a:t>
             </a:r>
             <a:endParaRPr lang="en-US" sz="2400" dirty="0"/>
           </a:p>

</xml_diff>